<commit_message>
render: W22 mon (auto-published from production-dispatcher)
</commit_message>
<xml_diff>
--- a/W22-5d03ac/mon/slides/01-cover.pptx
+++ b/W22-5d03ac/mon/slides/01-cover.pptx
@@ -3188,25 +3188,10 @@
                 </a:solidFill>
                 <a:latin typeface="Playfair Display"/>
               </a:rPr>
-              <a:t>Five things the Fort Lauderdale market is </a:t>
-            </a:r>
-            <a:r>
-              <a:rPr sz="5200" b="1" i="1">
-                <a:solidFill>
-                  <a:srgbClr val="540918"/>
-                </a:solidFill>
-                <a:latin typeface="Playfair Display"/>
-              </a:rPr>
-              <a:t>actually</a:t>
-            </a:r>
-            <a:r>
-              <a:rPr sz="5200" b="1" i="0">
-                <a:solidFill>
-                  <a:srgbClr val="F5F1EC"/>
-                </a:solidFill>
-                <a:latin typeface="Playfair Display"/>
-              </a:rPr>
-              <a:t> doing</a:t>
+              <a:t>The market isn't doing one thing.
+It's doing five.
+And they point in different directions.
+</a:t>
             </a:r>
           </a:p>
         </p:txBody>
@@ -3240,7 +3225,7 @@
                 </a:solidFill>
                 <a:latin typeface="Playfair Display"/>
               </a:rPr>
-              <a:t>Five numbers before you make your next move</a:t>
+              <a:t>Read this before you buy, sell, or do nothing. 5 slides. Real data. No BS.</a:t>
             </a:r>
           </a:p>
         </p:txBody>

</xml_diff>